<commit_message>
PW1/PW7: standardize Sun baseline names in papers and slides
Use Sun et al. (2024), shortened to Sun, with explicit local-reconstruction attribution. Preserve original attachments, frozen experiment sources, compatibility IDs and all numerical results. Validate document values, citations and reading-pack embeds; render both decks and verify only three slide parts change. Artifact-only checks; no experiment runs or test suites.
</commit_message>
<xml_diff>
--- a/formal_experiment/paper/presentations/LLM4BPC_Semantic_Extraction_Part3.pptx
+++ b/formal_experiment/paper/presentations/LLM4BPC_Semantic_Extraction_Part3.pptx
@@ -25446,7 +25446,7 @@
                 <a:latin typeface="Arial" panose="020B0604020202020204" pitchFamily="34" charset="0"/>
                 <a:ea typeface="微软雅黑" panose="020B0503020204020204" pitchFamily="34" charset="-122"/>
               </a:rPr>
-              <a:t>本部分沿用 </a:t>
+              <a:t>本地重建：</a:t>
             </a:r>
             <a:r>
               <a:rPr lang="en-US" altLang="zh-CN" sz="1200">
@@ -25472,7 +25472,7 @@
                 <a:latin typeface="Arial" panose="020B0604020202020204" pitchFamily="34" charset="0"/>
                 <a:ea typeface="微软雅黑" panose="020B0503020204020204" pitchFamily="34" charset="-122"/>
               </a:rPr>
-              <a:t>的流程模型拆解方法。</a:t>
+              <a:t/>
             </a:r>
             <a:endParaRPr lang="zh-CN" altLang="en-US" sz="1200">
               <a:solidFill>

</xml_diff>